<commit_message>
docs(pptx): diapositiva hero con dron animado (2 sensores escaneando la ciudad)
Añade una slide 2 con un GIF animado profesional (dron IoT + visión escaneando una
ciudad, con barrido en movimiento). Conserva fotos del equipo y demás contenido.
</commit_message>
<xml_diff>
--- a/docs/presentacion/VigIA-Equipo80.pptx
+++ b/docs/presentacion/VigIA-Equipo80.pptx
@@ -9,6 +9,7 @@
   </p:notesMasterIdLst>
   <p:sldIdLst>
     <p:sldId id="256" r:id="rId2"/>
+    <p:sldId id="277" r:id="rId28"/>
     <p:sldId id="257" r:id="rId3"/>
     <p:sldId id="258" r:id="rId4"/>
     <p:sldId id="259" r:id="rId5"/>
@@ -20478,6 +20479,56 @@
 </p:sld>
 </file>
 
+<file path=ppt/slides/slide22.xml><?xml version="1.0" encoding="utf-8"?>
+<p:sld xmlns:a="http://schemas.openxmlformats.org/drawingml/2006/main" xmlns:p="http://schemas.openxmlformats.org/presentationml/2006/main" xmlns:r="http://schemas.openxmlformats.org/officeDocument/2006/relationships">
+  <p:cSld>
+    <p:bg>
+      <p:bgPr>
+        <a:solidFill>
+          <a:srgbClr val="0F1A34"/>
+        </a:solidFill>
+        <a:effectLst/>
+      </p:bgPr>
+    </p:bg>
+    <p:spTree>
+      <p:nvGrpSpPr>
+        <p:cNvPr id="1" name=""/>
+        <p:cNvGrpSpPr/>
+        <p:nvPr/>
+      </p:nvGrpSpPr>
+      <p:grpSpPr/>
+      <p:pic>
+        <p:nvPicPr>
+          <p:cNvPr id="2" name="Picture 1" descr="drone_scan.gif"/>
+          <p:cNvPicPr>
+            <a:picLocks noChangeAspect="1"/>
+          </p:cNvPicPr>
+          <p:nvPr/>
+        </p:nvPicPr>
+        <p:blipFill>
+          <a:blip r:embed="rId2"/>
+          <a:stretch>
+            <a:fillRect/>
+          </a:stretch>
+        </p:blipFill>
+        <p:spPr>
+          <a:xfrm>
+            <a:off x="2185481" y="365760"/>
+            <a:ext cx="7821038" cy="6126480"/>
+          </a:xfrm>
+          <a:prstGeom prst="rect">
+            <a:avLst/>
+          </a:prstGeom>
+        </p:spPr>
+      </p:pic>
+    </p:spTree>
+  </p:cSld>
+  <p:clrMapOvr>
+    <a:masterClrMapping/>
+  </p:clrMapOvr>
+</p:sld>
+</file>
+
 <file path=ppt/slides/slide3.xml><?xml version="1.0" encoding="utf-8"?>
 <p:sld xmlns:a="http://schemas.openxmlformats.org/drawingml/2006/main" xmlns:r="http://schemas.openxmlformats.org/officeDocument/2006/relationships" xmlns:p="http://schemas.openxmlformats.org/presentationml/2006/main">
   <p:cSld name="Slide 3">

</xml_diff>